<commit_message>
Refine presentation scientific wording and failure-case visuals
</commit_message>
<xml_diff>
--- a/presentation/24CS2032_Dropout_Presentation.pptx
+++ b/presentation/24CS2032_Dropout_Presentation.pptx
@@ -5143,7 +5143,7 @@
               </a:defRPr>
             </a:pPr>
             <a:r>
-              <a:t>Lowest numerical test error occurred at d=0.3 (3.820 ± 0.118%). However, d=0.4 is the sole authorized selected model because test data was strictly quarantined from selection. (Delta: 0.023 pp is within noise).</a:t>
+              <a:t>Lowest numerical test error occurred at d=0.3 (3.820 ± 0.118%). The observed mean test-error difference between d=0.3 and d=0.4 is only 0.023 percentage points. Test performance was not used for model selection.</a:t>
             </a:r>
           </a:p>
           <a:p>
@@ -5484,7 +5484,7 @@
               </a:defRPr>
             </a:pPr>
             <a:r>
-              <a:t>Qualitative Replicability:</a:t>
+              <a:t>Qualitative Trend:</a:t>
             </a:r>
           </a:p>
           <a:p>
@@ -5499,7 +5499,7 @@
               </a:defRPr>
             </a:pPr>
             <a:r>
-              <a:t>Successfully reproduces Figure 9(a) U-shaped curve: intermediate retention probabilities provide optimal regularization; excessive dropout causes underfitting.</a:t>
+              <a:t>Our reduced-scale rate sweep shows a qualitatively similar non-monotonic trend: moderate dropout performs better than very high dropout under this fixed training budget.</a:t>
             </a:r>
           </a:p>
         </p:txBody>
@@ -5692,7 +5692,7 @@
               </a:defRPr>
             </a:pPr>
             <a:r>
-              <a:t>Dropout strength is highly task-sensitive. Fashion-MNIST features subtle textures and fine-grained visual cues; aggressive dropout suppresses critical features and induces underfitting.</a:t>
+              <a:t>Under the fixed 20-epoch budget, higher dropout rates produced higher train and test error on Fashion-MNIST, consistent with stronger underfitting.</a:t>
             </a:r>
           </a:p>
         </p:txBody>
@@ -5780,7 +5780,7 @@
               </a:defRPr>
             </a:pPr>
             <a:r>
-              <a:t>Failure Case Inspection and Experimental Limitations</a:t>
+              <a:t>Failure Case Inspection and Methodological Limitations</a:t>
             </a:r>
           </a:p>
         </p:txBody>
@@ -5838,6 +5838,600 @@
         </p:nvSpPr>
         <p:spPr>
           <a:xfrm>
+            <a:off x="731520" y="1463040"/>
+            <a:ext cx="6858000" cy="4937760"/>
+          </a:xfrm>
+          <a:prstGeom prst="rect">
+            <a:avLst/>
+          </a:prstGeom>
+          <a:solidFill>
+            <a:srgbClr val="F8FAFC"/>
+          </a:solidFill>
+          <a:ln>
+            <a:solidFill>
+              <a:srgbClr val="E2E8F0"/>
+            </a:solidFill>
+          </a:ln>
+        </p:spPr>
+        <p:style>
+          <a:lnRef idx="1">
+            <a:schemeClr val="accent1"/>
+          </a:lnRef>
+          <a:fillRef idx="3">
+            <a:schemeClr val="accent1"/>
+          </a:fillRef>
+          <a:effectRef idx="2">
+            <a:schemeClr val="accent1"/>
+          </a:effectRef>
+          <a:fontRef idx="minor">
+            <a:schemeClr val="lt1"/>
+          </a:fontRef>
+        </p:style>
+        <p:txBody>
+          <a:bodyPr rtlCol="0" anchor="ctr"/>
+          <a:lstStyle/>
+          <a:p>
+            <a:pPr algn="ctr"/>
+          </a:p>
+        </p:txBody>
+      </p:sp>
+      <p:sp>
+        <p:nvSpPr>
+          <p:cNvPr id="6" name="TextBox 5"/>
+          <p:cNvSpPr txBox="1"/>
+          <p:nvPr/>
+        </p:nvSpPr>
+        <p:spPr>
+          <a:xfrm>
+            <a:off x="868680" y="1554480"/>
+            <a:ext cx="6583680" cy="502920"/>
+          </a:xfrm>
+          <a:prstGeom prst="rect">
+            <a:avLst/>
+          </a:prstGeom>
+          <a:noFill/>
+        </p:spPr>
+        <p:txBody>
+          <a:bodyPr wrap="square" lIns="0" tIns="0" rIns="0" bIns="0">
+            <a:spAutoFit/>
+          </a:bodyPr>
+          <a:lstStyle/>
+          <a:p>
+            <a:pPr>
+              <a:defRPr sz="1200" b="1">
+                <a:solidFill>
+                  <a:srgbClr val="2563EB"/>
+                </a:solidFill>
+              </a:defRPr>
+            </a:pPr>
+            <a:r>
+              <a:t>MNIST Failure Cases (Selected d = 0.4):</a:t>
+            </a:r>
+          </a:p>
+          <a:p>
+            <a:pPr>
+              <a:defRPr sz="1000">
+                <a:solidFill>
+                  <a:srgbClr val="475569"/>
+                </a:solidFill>
+              </a:defRPr>
+            </a:pPr>
+            <a:r>
+              <a:t>Callouts: True 2 → Pred 3 (conf 0.52)   |   True 9 → Pred 8 (conf 0.91)</a:t>
+            </a:r>
+          </a:p>
+        </p:txBody>
+      </p:sp>
+      <p:pic>
+        <p:nvPicPr>
+          <p:cNvPr id="7" name="Picture 6" descr="mnist_failure_cases.png"/>
+          <p:cNvPicPr>
+            <a:picLocks noChangeAspect="1"/>
+          </p:cNvPicPr>
+          <p:nvPr/>
+        </p:nvPicPr>
+        <p:blipFill>
+          <a:blip r:embed="rId2"/>
+          <a:srcRect t="4861" b="63889"/>
+          <a:stretch>
+            <a:fillRect/>
+          </a:stretch>
+        </p:blipFill>
+        <p:spPr>
+          <a:xfrm>
+            <a:off x="868680" y="2103120"/>
+            <a:ext cx="6583680" cy="1371600"/>
+          </a:xfrm>
+          <a:prstGeom prst="rect">
+            <a:avLst/>
+          </a:prstGeom>
+        </p:spPr>
+      </p:pic>
+      <p:sp>
+        <p:nvSpPr>
+          <p:cNvPr id="8" name="TextBox 7"/>
+          <p:cNvSpPr txBox="1"/>
+          <p:nvPr/>
+        </p:nvSpPr>
+        <p:spPr>
+          <a:xfrm>
+            <a:off x="868680" y="3611880"/>
+            <a:ext cx="6583680" cy="502920"/>
+          </a:xfrm>
+          <a:prstGeom prst="rect">
+            <a:avLst/>
+          </a:prstGeom>
+          <a:noFill/>
+        </p:spPr>
+        <p:txBody>
+          <a:bodyPr wrap="square" lIns="0" tIns="0" rIns="0" bIns="0">
+            <a:spAutoFit/>
+          </a:bodyPr>
+          <a:lstStyle/>
+          <a:p>
+            <a:pPr>
+              <a:defRPr sz="1200" b="1">
+                <a:solidFill>
+                  <a:srgbClr val="2563EB"/>
+                </a:solidFill>
+              </a:defRPr>
+            </a:pPr>
+            <a:r>
+              <a:t>Fashion-MNIST Failure Cases (Selected d = 0.2):</a:t>
+            </a:r>
+          </a:p>
+          <a:p>
+            <a:pPr>
+              <a:defRPr sz="1000">
+                <a:solidFill>
+                  <a:srgbClr val="475569"/>
+                </a:solidFill>
+              </a:defRPr>
+            </a:pPr>
+            <a:r>
+              <a:t>Callouts: Coat → Pullover (conf 0.71)   |   Ankle boot → Sneaker (conf 0.99)</a:t>
+            </a:r>
+          </a:p>
+        </p:txBody>
+      </p:sp>
+      <p:pic>
+        <p:nvPicPr>
+          <p:cNvPr id="9" name="Picture 8" descr="fashion_failure_cases.png"/>
+          <p:cNvPicPr>
+            <a:picLocks noChangeAspect="1"/>
+          </p:cNvPicPr>
+          <p:nvPr/>
+        </p:nvPicPr>
+        <p:blipFill>
+          <a:blip r:embed="rId3"/>
+          <a:srcRect t="4861" b="63889"/>
+          <a:stretch>
+            <a:fillRect/>
+          </a:stretch>
+        </p:blipFill>
+        <p:spPr>
+          <a:xfrm>
+            <a:off x="868680" y="4160520"/>
+            <a:ext cx="6583680" cy="1371600"/>
+          </a:xfrm>
+          <a:prstGeom prst="rect">
+            <a:avLst/>
+          </a:prstGeom>
+        </p:spPr>
+      </p:pic>
+      <p:sp>
+        <p:nvSpPr>
+          <p:cNvPr id="10" name="TextBox 9"/>
+          <p:cNvSpPr txBox="1"/>
+          <p:nvPr/>
+        </p:nvSpPr>
+        <p:spPr>
+          <a:xfrm>
+            <a:off x="868680" y="5669280"/>
+            <a:ext cx="6583680" cy="594360"/>
+          </a:xfrm>
+          <a:prstGeom prst="rect">
+            <a:avLst/>
+          </a:prstGeom>
+          <a:noFill/>
+        </p:spPr>
+        <p:txBody>
+          <a:bodyPr wrap="square" lIns="0" tIns="0" rIns="0" bIns="0">
+            <a:spAutoFit/>
+          </a:bodyPr>
+          <a:lstStyle/>
+          <a:p>
+            <a:pPr>
+              <a:defRPr sz="950" i="1">
+                <a:solidFill>
+                  <a:srgbClr val="475569"/>
+                </a:solidFill>
+              </a:defRPr>
+            </a:pPr>
+            <a:r>
+              <a:t>Note: Errors reflect visual stroke &amp; silhouette ambiguities at 28×28 resolution without spatial convolutional inductive bias.</a:t>
+            </a:r>
+          </a:p>
+        </p:txBody>
+      </p:sp>
+      <p:sp>
+        <p:nvSpPr>
+          <p:cNvPr id="11" name="Rectangle 10"/>
+          <p:cNvSpPr/>
+          <p:nvPr/>
+        </p:nvSpPr>
+        <p:spPr>
+          <a:xfrm>
+            <a:off x="7772400" y="1463040"/>
+            <a:ext cx="3687775" cy="4937760"/>
+          </a:xfrm>
+          <a:prstGeom prst="rect">
+            <a:avLst/>
+          </a:prstGeom>
+          <a:solidFill>
+            <a:srgbClr val="F8FAFC"/>
+          </a:solidFill>
+          <a:ln>
+            <a:solidFill>
+              <a:srgbClr val="E2E8F0"/>
+            </a:solidFill>
+          </a:ln>
+        </p:spPr>
+        <p:style>
+          <a:lnRef idx="1">
+            <a:schemeClr val="accent1"/>
+          </a:lnRef>
+          <a:fillRef idx="3">
+            <a:schemeClr val="accent1"/>
+          </a:fillRef>
+          <a:effectRef idx="2">
+            <a:schemeClr val="accent1"/>
+          </a:effectRef>
+          <a:fontRef idx="minor">
+            <a:schemeClr val="lt1"/>
+          </a:fontRef>
+        </p:style>
+        <p:txBody>
+          <a:bodyPr rtlCol="0" anchor="ctr" wrap="square" lIns="274320" tIns="274320" rIns="274320" bIns="274320"/>
+          <a:lstStyle/>
+          <a:p>
+            <a:pPr algn="ctr">
+              <a:spcAft>
+                <a:spcPts val="800"/>
+              </a:spcAft>
+              <a:defRPr sz="1400" b="1">
+                <a:solidFill>
+                  <a:srgbClr val="1E3A8A"/>
+                </a:solidFill>
+              </a:defRPr>
+            </a:pPr>
+            <a:r>
+              <a:t>Methodological Constraints &amp; Scope</a:t>
+            </a:r>
+          </a:p>
+          <a:p>
+            <a:pPr>
+              <a:spcAft>
+                <a:spcPts val="100"/>
+              </a:spcAft>
+              <a:defRPr sz="1100" b="1">
+                <a:solidFill>
+                  <a:srgbClr val="2563EB"/>
+                </a:solidFill>
+              </a:defRPr>
+            </a:pPr>
+            <a:r>
+              <a:t>• 3 random seeds only:</a:t>
+            </a:r>
+          </a:p>
+          <a:p>
+            <a:pPr>
+              <a:spcAft>
+                <a:spcPts val="500"/>
+              </a:spcAft>
+              <a:defRPr sz="1000">
+                <a:solidFill>
+                  <a:srgbClr val="0F172A"/>
+                </a:solidFill>
+              </a:defRPr>
+            </a:pPr>
+            <a:r>
+              <a:t>N=3 reflects empirical sample variance but lacks statistical power for formal hypothesis testing.</a:t>
+            </a:r>
+          </a:p>
+          <a:p>
+            <a:pPr>
+              <a:spcAft>
+                <a:spcPts val="100"/>
+              </a:spcAft>
+              <a:defRPr sz="1100" b="1">
+                <a:solidFill>
+                  <a:srgbClr val="2563EB"/>
+                </a:solidFill>
+              </a:defRPr>
+            </a:pPr>
+            <a:r>
+              <a:t>• 10k training subset:</a:t>
+            </a:r>
+          </a:p>
+          <a:p>
+            <a:pPr>
+              <a:spcAft>
+                <a:spcPts val="500"/>
+              </a:spcAft>
+              <a:defRPr sz="1000">
+                <a:solidFill>
+                  <a:srgbClr val="0F172A"/>
+                </a:solidFill>
+              </a:defRPr>
+            </a:pPr>
+            <a:r>
+              <a:t>Subsampled training split magnifies regularizer sensitivity relative to the full 60,000 dataset.</a:t>
+            </a:r>
+          </a:p>
+          <a:p>
+            <a:pPr>
+              <a:spcAft>
+                <a:spcPts val="100"/>
+              </a:spcAft>
+              <a:defRPr sz="1100" b="1">
+                <a:solidFill>
+                  <a:srgbClr val="2563EB"/>
+                </a:solidFill>
+              </a:defRPr>
+            </a:pPr>
+            <a:r>
+              <a:t>• Fixed 20-epoch budget:</a:t>
+            </a:r>
+          </a:p>
+          <a:p>
+            <a:pPr>
+              <a:spcAft>
+                <a:spcPts val="500"/>
+              </a:spcAft>
+              <a:defRPr sz="1000">
+                <a:solidFill>
+                  <a:srgbClr val="0F172A"/>
+                </a:solidFill>
+              </a:defRPr>
+            </a:pPr>
+            <a:r>
+              <a:t>Higher dropout may require more optimization; this experiment intentionally keeps the same 20-epoch budget for every rate.</a:t>
+            </a:r>
+          </a:p>
+          <a:p>
+            <a:pPr>
+              <a:spcAft>
+                <a:spcPts val="100"/>
+              </a:spcAft>
+              <a:defRPr sz="1100" b="1">
+                <a:solidFill>
+                  <a:srgbClr val="2563EB"/>
+                </a:solidFill>
+              </a:defRPr>
+            </a:pPr>
+            <a:r>
+              <a:t>• Fully connected MLP:</a:t>
+            </a:r>
+          </a:p>
+          <a:p>
+            <a:pPr>
+              <a:spcAft>
+                <a:spcPts val="500"/>
+              </a:spcAft>
+              <a:defRPr sz="1000">
+                <a:solidFill>
+                  <a:srgbClr val="0F172A"/>
+                </a:solidFill>
+              </a:defRPr>
+            </a:pPr>
+            <a:r>
+              <a:t>Lacks the translational invariance of convolutional networks.</a:t>
+            </a:r>
+          </a:p>
+          <a:p>
+            <a:pPr>
+              <a:spcAft>
+                <a:spcPts val="100"/>
+              </a:spcAft>
+              <a:defRPr sz="1100" b="1">
+                <a:solidFill>
+                  <a:srgbClr val="2563EB"/>
+                </a:solidFill>
+              </a:defRPr>
+            </a:pPr>
+            <a:r>
+              <a:t>• No significance test:</a:t>
+            </a:r>
+          </a:p>
+          <a:p>
+            <a:pPr>
+              <a:spcAft>
+                <a:spcPts val="500"/>
+              </a:spcAft>
+              <a:defRPr sz="1000">
+                <a:solidFill>
+                  <a:srgbClr val="0F172A"/>
+                </a:solidFill>
+              </a:defRPr>
+            </a:pPr>
+            <a:r>
+              <a:t>Sample SD (ddof=1) reported; descriptive comparisons only without p-values.</a:t>
+            </a:r>
+          </a:p>
+          <a:p>
+            <a:pPr>
+              <a:spcAft>
+                <a:spcPts val="100"/>
+              </a:spcAft>
+              <a:defRPr sz="1100" b="1">
+                <a:solidFill>
+                  <a:srgbClr val="2563EB"/>
+                </a:solidFill>
+              </a:defRPr>
+            </a:pPr>
+            <a:r>
+              <a:t>• Fashion-MNIST is an extension:</a:t>
+            </a:r>
+          </a:p>
+          <a:p>
+            <a:pPr>
+              <a:spcAft>
+                <a:spcPts val="500"/>
+              </a:spcAft>
+              <a:defRPr sz="1000">
+                <a:solidFill>
+                  <a:srgbClr val="0F172A"/>
+                </a:solidFill>
+              </a:defRPr>
+            </a:pPr>
+            <a:r>
+              <a:t>Exploratory benchmark under the identical protocol (not present in 2014 paper).</a:t>
+            </a:r>
+          </a:p>
+        </p:txBody>
+      </p:sp>
+    </p:spTree>
+  </p:cSld>
+  <p:clrMapOvr>
+    <a:masterClrMapping/>
+  </p:clrMapOvr>
+</p:sld>
+</file>
+
+<file path=ppt/slides/slide8.xml><?xml version="1.0" encoding="utf-8"?>
+<p:sld xmlns:a="http://schemas.openxmlformats.org/drawingml/2006/main" xmlns:p="http://schemas.openxmlformats.org/presentationml/2006/main" xmlns:r="http://schemas.openxmlformats.org/officeDocument/2006/relationships">
+  <p:cSld>
+    <p:spTree>
+      <p:nvGrpSpPr>
+        <p:cNvPr id="1" name=""/>
+        <p:cNvGrpSpPr/>
+        <p:nvPr/>
+      </p:nvGrpSpPr>
+      <p:grpSpPr/>
+      <p:sp>
+        <p:nvSpPr>
+          <p:cNvPr id="2" name="TextBox 1"/>
+          <p:cNvSpPr txBox="1"/>
+          <p:nvPr/>
+        </p:nvSpPr>
+        <p:spPr>
+          <a:xfrm>
+            <a:off x="731520" y="365760"/>
+            <a:ext cx="10698480" cy="320040"/>
+          </a:xfrm>
+          <a:prstGeom prst="rect">
+            <a:avLst/>
+          </a:prstGeom>
+          <a:noFill/>
+        </p:spPr>
+        <p:txBody>
+          <a:bodyPr wrap="square" lIns="0" tIns="0" rIns="0" bIns="0">
+            <a:spAutoFit/>
+          </a:bodyPr>
+          <a:lstStyle/>
+          <a:p>
+            <a:pPr>
+              <a:defRPr sz="1000" b="1">
+                <a:solidFill>
+                  <a:srgbClr val="2563EB"/>
+                </a:solidFill>
+              </a:defRPr>
+            </a:pPr>
+            <a:r>
+              <a:t>24CS2032 DEEP LEARNING — PAPER IMPLEMENTATION STUDY</a:t>
+            </a:r>
+          </a:p>
+        </p:txBody>
+      </p:sp>
+      <p:sp>
+        <p:nvSpPr>
+          <p:cNvPr id="3" name="TextBox 2"/>
+          <p:cNvSpPr txBox="1"/>
+          <p:nvPr/>
+        </p:nvSpPr>
+        <p:spPr>
+          <a:xfrm>
+            <a:off x="731520" y="685800"/>
+            <a:ext cx="10698480" cy="548640"/>
+          </a:xfrm>
+          <a:prstGeom prst="rect">
+            <a:avLst/>
+          </a:prstGeom>
+          <a:noFill/>
+        </p:spPr>
+        <p:txBody>
+          <a:bodyPr wrap="square" lIns="0" tIns="0" rIns="0" bIns="0">
+            <a:spAutoFit/>
+          </a:bodyPr>
+          <a:lstStyle/>
+          <a:p>
+            <a:pPr>
+              <a:defRPr sz="2400" b="1">
+                <a:solidFill>
+                  <a:srgbClr val="0F172A"/>
+                </a:solidFill>
+              </a:defRPr>
+            </a:pPr>
+            <a:r>
+              <a:t>Conclusion, Live Model Demo &amp; Resources</a:t>
+            </a:r>
+          </a:p>
+        </p:txBody>
+      </p:sp>
+      <p:sp>
+        <p:nvSpPr>
+          <p:cNvPr id="4" name="Rectangle 3"/>
+          <p:cNvSpPr/>
+          <p:nvPr/>
+        </p:nvSpPr>
+        <p:spPr>
+          <a:xfrm>
+            <a:off x="731520" y="1280160"/>
+            <a:ext cx="10728655" cy="18288"/>
+          </a:xfrm>
+          <a:prstGeom prst="rect">
+            <a:avLst/>
+          </a:prstGeom>
+          <a:solidFill>
+            <a:srgbClr val="E2E8F0"/>
+          </a:solidFill>
+          <a:ln>
+            <a:solidFill>
+              <a:srgbClr val="E2E8F0"/>
+            </a:solidFill>
+          </a:ln>
+        </p:spPr>
+        <p:style>
+          <a:lnRef idx="1">
+            <a:schemeClr val="accent1"/>
+          </a:lnRef>
+          <a:fillRef idx="3">
+            <a:schemeClr val="accent1"/>
+          </a:fillRef>
+          <a:effectRef idx="2">
+            <a:schemeClr val="accent1"/>
+          </a:effectRef>
+          <a:fontRef idx="minor">
+            <a:schemeClr val="lt1"/>
+          </a:fontRef>
+        </p:style>
+        <p:txBody>
+          <a:bodyPr rtlCol="0" anchor="ctr"/>
+          <a:lstStyle/>
+          <a:p>
+            <a:pPr algn="ctr"/>
+          </a:p>
+        </p:txBody>
+      </p:sp>
+      <p:sp>
+        <p:nvSpPr>
+          <p:cNvPr id="5" name="Rectangle 4"/>
+          <p:cNvSpPr/>
+          <p:nvPr/>
+        </p:nvSpPr>
+        <p:spPr>
+          <a:xfrm>
             <a:off x="731520" y="1554480"/>
             <a:ext cx="5120640" cy="4754880"/>
           </a:xfrm>
@@ -5873,31 +6467,31 @@
           <a:p>
             <a:pPr algn="ctr">
               <a:spcAft>
+                <a:spcPts val="1000"/>
+              </a:spcAft>
+              <a:defRPr sz="1500" b="1">
+                <a:solidFill>
+                  <a:srgbClr val="1E3A8A"/>
+                </a:solidFill>
+              </a:defRPr>
+            </a:pPr>
+            <a:r>
+              <a:t>Key Research Conclusions</a:t>
+            </a:r>
+          </a:p>
+          <a:p>
+            <a:pPr>
+              <a:spcAft>
                 <a:spcPts val="800"/>
               </a:spcAft>
-              <a:defRPr sz="1500" b="1">
-                <a:solidFill>
-                  <a:srgbClr val="1E3A8A"/>
-                </a:solidFill>
-              </a:defRPr>
-            </a:pPr>
-            <a:r>
-              <a:t>Inspection of Misclassified Test Samples</a:t>
-            </a:r>
-          </a:p>
-          <a:p>
-            <a:pPr>
-              <a:spcAft>
-                <a:spcPts val="200"/>
-              </a:spcAft>
-              <a:defRPr sz="1200" b="1">
-                <a:solidFill>
-                  <a:srgbClr val="2563EB"/>
-                </a:solidFill>
-              </a:defRPr>
-            </a:pPr>
-            <a:r>
-              <a:t>MNIST Failure Cases (Selected d = 0.4):</a:t>
+              <a:defRPr sz="1100">
+                <a:solidFill>
+                  <a:srgbClr val="0F172A"/>
+                </a:solidFill>
+              </a:defRPr>
+            </a:pPr>
+            <a:r>
+              <a:t>1. Complete Mathematical Implementation: Inverted dropout was built and verified from scratch without any built-in library dependencies.</a:t>
             </a:r>
           </a:p>
           <a:p>
@@ -5912,26 +6506,15 @@
               </a:defRPr>
             </a:pPr>
             <a:r>
-              <a:t>• True 2 -&gt; Predicted 3 (conf 0.52): Open lower loop visually resembles numeral 3.</a:t>
+              <a:t>2. Regularization Efficacy: Moderate validation-selected dropout lowered mean test error relative to the no-dropout baseline in our fixed protocol:</a:t>
             </a:r>
             <a:br/>
             <a:r>
-              <a:t>• True 9 -&gt; Predicted 8 (conf 0.91): Curved ascender stroke resembles top loop of numeral 8.</a:t>
-            </a:r>
-          </a:p>
-          <a:p>
-            <a:pPr>
-              <a:spcAft>
-                <a:spcPts val="200"/>
-              </a:spcAft>
-              <a:defRPr sz="1200" b="1">
-                <a:solidFill>
-                  <a:srgbClr val="2563EB"/>
-                </a:solidFill>
-              </a:defRPr>
-            </a:pPr>
-            <a:r>
-              <a:t>Fashion-MNIST Failure Cases (Selected d = 0.2):</a:t>
+              <a:t>   • MNIST: 4.320% -&gt; 3.843% test error (11.03% relative reduction)</a:t>
+            </a:r>
+            <a:br/>
+            <a:r>
+              <a:t>   • Fashion-MNIST: 14.663% -&gt; 14.347% test error (2.16% relative reduction)</a:t>
             </a:r>
           </a:p>
           <a:p>
@@ -5946,26 +6529,7 @@
               </a:defRPr>
             </a:pPr>
             <a:r>
-              <a:t>• True Coat -&gt; Predicted Pullover (conf 0.71): Shares global torso silhouette and neckline.</a:t>
-            </a:r>
-            <a:br/>
-            <a:r>
-              <a:t>• True Ankle Boot -&gt; Predicted Sneaker (conf 0.99): Low-cut ankle profile resembles casual shoe.</a:t>
-            </a:r>
-          </a:p>
-          <a:p>
-            <a:pPr>
-              <a:spcAft>
-                <a:spcPts val="200"/>
-              </a:spcAft>
-              <a:defRPr sz="1200" b="1">
-                <a:solidFill>
-                  <a:srgbClr val="2563EB"/>
-                </a:solidFill>
-              </a:defRPr>
-            </a:pPr>
-            <a:r>
-              <a:t>Observational Insight:</a:t>
+              <a:t>3. Critical Negative Finding: Canonical d = 0.5 underperformed the no-dropout baseline on Fashion-MNIST, and rates d &gt;= 0.6 caused underfitting on both benchmarks.</a:t>
             </a:r>
           </a:p>
           <a:p>
@@ -5980,7 +6544,7 @@
               </a:defRPr>
             </a:pPr>
             <a:r>
-              <a:t>At 28x28 grayscale resolution, fine texture boundaries are challenging for MLPs lacking spatial convolutional inductive bias. We describe visual stroke similarities rather than claiming proven causal latent mechanisms.</a:t>
+              <a:t>4. Methodological Lesson: Dropout strength cannot be assumed universally; it must be calibrated systematically against validation data.</a:t>
             </a:r>
           </a:p>
         </p:txBody>
@@ -6037,7 +6601,7 @@
               </a:defRPr>
             </a:pPr>
             <a:r>
-              <a:t>Methodological Constraints &amp; Scope</a:t>
+              <a:t>Saved-Model Demonstration &amp; Project Assets</a:t>
             </a:r>
           </a:p>
           <a:p>
@@ -6052,495 +6616,34 @@
               </a:defRPr>
             </a:pPr>
             <a:r>
-              <a:t>1. Small Seed Sample Size (N = 3):</a:t>
-            </a:r>
-          </a:p>
-          <a:p>
-            <a:pPr>
-              <a:spcAft>
-                <a:spcPts val="600"/>
-              </a:spcAft>
-              <a:defRPr sz="1100">
+              <a:t>Interactive Demo (presentation/demo.py):</a:t>
+            </a:r>
+          </a:p>
+          <a:p>
+            <a:pPr>
+              <a:spcAft>
+                <a:spcPts val="700"/>
+              </a:spcAft>
+              <a:defRPr sz="1050">
                 <a:solidFill>
                   <a:srgbClr val="0F172A"/>
                 </a:solidFill>
               </a:defRPr>
             </a:pPr>
             <a:r>
-              <a:t>Evaluating over seeds {42, 43, 44} reflects empirical variance, but N=3 lacks statistical power for formal hypothesis testing.</a:t>
-            </a:r>
-          </a:p>
-          <a:p>
-            <a:pPr>
-              <a:spcAft>
-                <a:spcPts val="100"/>
-              </a:spcAft>
-              <a:defRPr sz="1200" b="1">
-                <a:solidFill>
-                  <a:srgbClr val="2563EB"/>
-                </a:solidFill>
-              </a:defRPr>
-            </a:pPr>
-            <a:r>
-              <a:t>2. Fixed 20-Epoch Training Horizon:</a:t>
-            </a:r>
-          </a:p>
-          <a:p>
-            <a:pPr>
-              <a:spcAft>
-                <a:spcPts val="600"/>
-              </a:spcAft>
-              <a:defRPr sz="1100">
-                <a:solidFill>
-                  <a:srgbClr val="0F172A"/>
-                </a:solidFill>
-              </a:defRPr>
-            </a:pPr>
-            <a:r>
-              <a:t>High dropout rates inherently retard convergence; additional epochs might partially recover performance for d &gt;= 0.5.</a:t>
-            </a:r>
-          </a:p>
-          <a:p>
-            <a:pPr>
-              <a:spcAft>
-                <a:spcPts val="100"/>
-              </a:spcAft>
-              <a:defRPr sz="1200" b="1">
-                <a:solidFill>
-                  <a:srgbClr val="2563EB"/>
-                </a:solidFill>
-              </a:defRPr>
-            </a:pPr>
-            <a:r>
-              <a:t>3. Subsampled 10k Training Split:</a:t>
-            </a:r>
-          </a:p>
-          <a:p>
-            <a:pPr>
-              <a:spcAft>
-                <a:spcPts val="600"/>
-              </a:spcAft>
-              <a:defRPr sz="1100">
-                <a:solidFill>
-                  <a:srgbClr val="0F172A"/>
-                </a:solidFill>
-              </a:defRPr>
-            </a:pPr>
-            <a:r>
-              <a:t>10,000 examples magnifies regularizer sensitivity relative to the standard 60,000 dataset.</a:t>
-            </a:r>
-          </a:p>
-          <a:p>
-            <a:pPr>
-              <a:spcAft>
-                <a:spcPts val="100"/>
-              </a:spcAft>
-              <a:defRPr sz="1200" b="1">
-                <a:solidFill>
-                  <a:srgbClr val="2563EB"/>
-                </a:solidFill>
-              </a:defRPr>
-            </a:pPr>
-            <a:r>
-              <a:t>4. Network Architecture:</a:t>
-            </a:r>
-          </a:p>
-          <a:p>
-            <a:pPr>
-              <a:spcAft>
-                <a:spcPts val="600"/>
-              </a:spcAft>
-              <a:defRPr sz="1100">
-                <a:solidFill>
-                  <a:srgbClr val="0F172A"/>
-                </a:solidFill>
-              </a:defRPr>
-            </a:pPr>
-            <a:r>
-              <a:t>Fully connected MLPs lack translational invariance of CNNs.</a:t>
-            </a:r>
-          </a:p>
-          <a:p>
-            <a:pPr>
-              <a:spcAft>
-                <a:spcPts val="100"/>
-              </a:spcAft>
-              <a:defRPr sz="1200" b="1">
-                <a:solidFill>
-                  <a:srgbClr val="2563EB"/>
-                </a:solidFill>
-              </a:defRPr>
-            </a:pPr>
-            <a:r>
-              <a:t>5. Extension Scope:</a:t>
-            </a:r>
-          </a:p>
-          <a:p>
-            <a:pPr>
-              <a:spcAft>
-                <a:spcPts val="600"/>
-              </a:spcAft>
-              <a:defRPr sz="1100">
-                <a:solidFill>
-                  <a:srgbClr val="0F172A"/>
-                </a:solidFill>
-              </a:defRPr>
-            </a:pPr>
-            <a:r>
-              <a:t>Fashion-MNIST was evaluated strictly as an exploratory extension benchmark under the same protocol (not part of the 2014 paper).</a:t>
-            </a:r>
-          </a:p>
-        </p:txBody>
-      </p:sp>
-    </p:spTree>
-  </p:cSld>
-  <p:clrMapOvr>
-    <a:masterClrMapping/>
-  </p:clrMapOvr>
-</p:sld>
-</file>
-
-<file path=ppt/slides/slide8.xml><?xml version="1.0" encoding="utf-8"?>
-<p:sld xmlns:a="http://schemas.openxmlformats.org/drawingml/2006/main" xmlns:p="http://schemas.openxmlformats.org/presentationml/2006/main" xmlns:r="http://schemas.openxmlformats.org/officeDocument/2006/relationships">
-  <p:cSld>
-    <p:spTree>
-      <p:nvGrpSpPr>
-        <p:cNvPr id="1" name=""/>
-        <p:cNvGrpSpPr/>
-        <p:nvPr/>
-      </p:nvGrpSpPr>
-      <p:grpSpPr/>
-      <p:sp>
-        <p:nvSpPr>
-          <p:cNvPr id="2" name="TextBox 1"/>
-          <p:cNvSpPr txBox="1"/>
-          <p:nvPr/>
-        </p:nvSpPr>
-        <p:spPr>
-          <a:xfrm>
-            <a:off x="731520" y="365760"/>
-            <a:ext cx="10698480" cy="320040"/>
-          </a:xfrm>
-          <a:prstGeom prst="rect">
-            <a:avLst/>
-          </a:prstGeom>
-          <a:noFill/>
-        </p:spPr>
-        <p:txBody>
-          <a:bodyPr wrap="square" lIns="0" tIns="0" rIns="0" bIns="0">
-            <a:spAutoFit/>
-          </a:bodyPr>
-          <a:lstStyle/>
-          <a:p>
-            <a:pPr>
-              <a:defRPr sz="1000" b="1">
-                <a:solidFill>
-                  <a:srgbClr val="2563EB"/>
-                </a:solidFill>
-              </a:defRPr>
-            </a:pPr>
-            <a:r>
-              <a:t>24CS2032 DEEP LEARNING — PAPER IMPLEMENTATION STUDY</a:t>
-            </a:r>
-          </a:p>
-        </p:txBody>
-      </p:sp>
-      <p:sp>
-        <p:nvSpPr>
-          <p:cNvPr id="3" name="TextBox 2"/>
-          <p:cNvSpPr txBox="1"/>
-          <p:nvPr/>
-        </p:nvSpPr>
-        <p:spPr>
-          <a:xfrm>
-            <a:off x="731520" y="685800"/>
-            <a:ext cx="10698480" cy="548640"/>
-          </a:xfrm>
-          <a:prstGeom prst="rect">
-            <a:avLst/>
-          </a:prstGeom>
-          <a:noFill/>
-        </p:spPr>
-        <p:txBody>
-          <a:bodyPr wrap="square" lIns="0" tIns="0" rIns="0" bIns="0">
-            <a:spAutoFit/>
-          </a:bodyPr>
-          <a:lstStyle/>
-          <a:p>
-            <a:pPr>
-              <a:defRPr sz="2400" b="1">
-                <a:solidFill>
-                  <a:srgbClr val="0F172A"/>
-                </a:solidFill>
-              </a:defRPr>
-            </a:pPr>
-            <a:r>
-              <a:t>Conclusion, Live Model Demo &amp; Resources</a:t>
-            </a:r>
-          </a:p>
-        </p:txBody>
-      </p:sp>
-      <p:sp>
-        <p:nvSpPr>
-          <p:cNvPr id="4" name="Rectangle 3"/>
-          <p:cNvSpPr/>
-          <p:nvPr/>
-        </p:nvSpPr>
-        <p:spPr>
-          <a:xfrm>
-            <a:off x="731520" y="1280160"/>
-            <a:ext cx="10728655" cy="18288"/>
-          </a:xfrm>
-          <a:prstGeom prst="rect">
-            <a:avLst/>
-          </a:prstGeom>
-          <a:solidFill>
-            <a:srgbClr val="E2E8F0"/>
-          </a:solidFill>
-          <a:ln>
-            <a:solidFill>
-              <a:srgbClr val="E2E8F0"/>
-            </a:solidFill>
-          </a:ln>
-        </p:spPr>
-        <p:style>
-          <a:lnRef idx="1">
-            <a:schemeClr val="accent1"/>
-          </a:lnRef>
-          <a:fillRef idx="3">
-            <a:schemeClr val="accent1"/>
-          </a:fillRef>
-          <a:effectRef idx="2">
-            <a:schemeClr val="accent1"/>
-          </a:effectRef>
-          <a:fontRef idx="minor">
-            <a:schemeClr val="lt1"/>
-          </a:fontRef>
-        </p:style>
-        <p:txBody>
-          <a:bodyPr rtlCol="0" anchor="ctr"/>
-          <a:lstStyle/>
-          <a:p>
-            <a:pPr algn="ctr"/>
-          </a:p>
-        </p:txBody>
-      </p:sp>
-      <p:sp>
-        <p:nvSpPr>
-          <p:cNvPr id="5" name="Rectangle 4"/>
-          <p:cNvSpPr/>
-          <p:nvPr/>
-        </p:nvSpPr>
-        <p:spPr>
-          <a:xfrm>
-            <a:off x="731520" y="1554480"/>
-            <a:ext cx="5120640" cy="4754880"/>
-          </a:xfrm>
-          <a:prstGeom prst="rect">
-            <a:avLst/>
-          </a:prstGeom>
-          <a:solidFill>
-            <a:srgbClr val="F8FAFC"/>
-          </a:solidFill>
-          <a:ln>
-            <a:solidFill>
-              <a:srgbClr val="E2E8F0"/>
-            </a:solidFill>
-          </a:ln>
-        </p:spPr>
-        <p:style>
-          <a:lnRef idx="1">
-            <a:schemeClr val="accent1"/>
-          </a:lnRef>
-          <a:fillRef idx="3">
-            <a:schemeClr val="accent1"/>
-          </a:fillRef>
-          <a:effectRef idx="2">
-            <a:schemeClr val="accent1"/>
-          </a:effectRef>
-          <a:fontRef idx="minor">
-            <a:schemeClr val="lt1"/>
-          </a:fontRef>
-        </p:style>
-        <p:txBody>
-          <a:bodyPr rtlCol="0" anchor="ctr" wrap="square" lIns="274320" tIns="274320" rIns="274320" bIns="274320"/>
-          <a:lstStyle/>
-          <a:p>
-            <a:pPr algn="ctr">
-              <a:spcAft>
-                <a:spcPts val="1000"/>
-              </a:spcAft>
-              <a:defRPr sz="1500" b="1">
-                <a:solidFill>
-                  <a:srgbClr val="1E3A8A"/>
-                </a:solidFill>
-              </a:defRPr>
-            </a:pPr>
-            <a:r>
-              <a:t>Key Research Conclusions</a:t>
-            </a:r>
-          </a:p>
-          <a:p>
-            <a:pPr>
-              <a:spcAft>
-                <a:spcPts val="800"/>
-              </a:spcAft>
-              <a:defRPr sz="1100">
-                <a:solidFill>
-                  <a:srgbClr val="0F172A"/>
-                </a:solidFill>
-              </a:defRPr>
-            </a:pPr>
-            <a:r>
-              <a:t>1. Complete Mathematical Implementation: Inverted dropout was built and verified from scratch without any built-in library dependencies.</a:t>
-            </a:r>
-          </a:p>
-          <a:p>
-            <a:pPr>
-              <a:spcAft>
-                <a:spcPts val="800"/>
-              </a:spcAft>
-              <a:defRPr sz="1100">
-                <a:solidFill>
-                  <a:srgbClr val="0F172A"/>
-                </a:solidFill>
-              </a:defRPr>
-            </a:pPr>
-            <a:r>
-              <a:t>2. Regularization Efficacy: Moderate validation-selected dropout reliably lowered generalization error on both benchmarks:</a:t>
+              <a:t>• Loads saved checkpoint: mnist_d0.4_s42.pt on CPU</a:t>
             </a:r>
             <a:br/>
             <a:r>
-              <a:t>   • MNIST: 4.320% -&gt; 3.843% test error (11.03% relative reduction)</a:t>
+              <a:t>• First 10 MNIST test samples: 10/10 correct in the demo.</a:t>
             </a:r>
             <a:br/>
             <a:r>
-              <a:t>   • Fashion-MNIST: 14.663% -&gt; 14.347% test error (2.16% relative reduction)</a:t>
-            </a:r>
-          </a:p>
-          <a:p>
-            <a:pPr>
-              <a:spcAft>
-                <a:spcPts val="800"/>
-              </a:spcAft>
-              <a:defRPr sz="1100">
-                <a:solidFill>
-                  <a:srgbClr val="0F172A"/>
-                </a:solidFill>
-              </a:defRPr>
-            </a:pPr>
-            <a:r>
-              <a:t>3. Critical Negative Finding: Canonical d = 0.5 underperformed the no-dropout baseline on Fashion-MNIST, and rates d &gt;= 0.6 caused underfitting on both benchmarks.</a:t>
-            </a:r>
-          </a:p>
-          <a:p>
-            <a:pPr>
-              <a:spcAft>
-                <a:spcPts val="800"/>
-              </a:spcAft>
-              <a:defRPr sz="1100">
-                <a:solidFill>
-                  <a:srgbClr val="0F172A"/>
-                </a:solidFill>
-              </a:defRPr>
-            </a:pPr>
-            <a:r>
-              <a:t>4. Methodological Lesson: Dropout strength cannot be assumed universally; it must be calibrated systematically against validation data.</a:t>
-            </a:r>
-          </a:p>
-        </p:txBody>
-      </p:sp>
-      <p:sp>
-        <p:nvSpPr>
-          <p:cNvPr id="6" name="Rectangle 5"/>
-          <p:cNvSpPr/>
-          <p:nvPr/>
-        </p:nvSpPr>
-        <p:spPr>
-          <a:xfrm>
-            <a:off x="6217920" y="1554480"/>
-            <a:ext cx="5242255" cy="4754880"/>
-          </a:xfrm>
-          <a:prstGeom prst="rect">
-            <a:avLst/>
-          </a:prstGeom>
-          <a:solidFill>
-            <a:srgbClr val="F8FAFC"/>
-          </a:solidFill>
-          <a:ln>
-            <a:solidFill>
-              <a:srgbClr val="E2E8F0"/>
-            </a:solidFill>
-          </a:ln>
-        </p:spPr>
-        <p:style>
-          <a:lnRef idx="1">
-            <a:schemeClr val="accent1"/>
-          </a:lnRef>
-          <a:fillRef idx="3">
-            <a:schemeClr val="accent1"/>
-          </a:fillRef>
-          <a:effectRef idx="2">
-            <a:schemeClr val="accent1"/>
-          </a:effectRef>
-          <a:fontRef idx="minor">
-            <a:schemeClr val="lt1"/>
-          </a:fontRef>
-        </p:style>
-        <p:txBody>
-          <a:bodyPr rtlCol="0" anchor="ctr" wrap="square" lIns="274320" tIns="274320" rIns="274320" bIns="274320"/>
-          <a:lstStyle/>
-          <a:p>
-            <a:pPr algn="ctr">
-              <a:spcAft>
-                <a:spcPts val="1000"/>
-              </a:spcAft>
-              <a:defRPr sz="1500" b="1">
-                <a:solidFill>
-                  <a:srgbClr val="1E3A8A"/>
-                </a:solidFill>
-              </a:defRPr>
-            </a:pPr>
-            <a:r>
-              <a:t>Saved-Model Demonstration &amp; Project Assets</a:t>
-            </a:r>
-          </a:p>
-          <a:p>
-            <a:pPr>
-              <a:spcAft>
-                <a:spcPts val="100"/>
-              </a:spcAft>
-              <a:defRPr sz="1200" b="1">
-                <a:solidFill>
-                  <a:srgbClr val="2563EB"/>
-                </a:solidFill>
-              </a:defRPr>
-            </a:pPr>
-            <a:r>
-              <a:t>Interactive Demo (presentation/demo.py):</a:t>
-            </a:r>
-          </a:p>
-          <a:p>
-            <a:pPr>
-              <a:spcAft>
-                <a:spcPts val="700"/>
-              </a:spcAft>
-              <a:defRPr sz="1050">
-                <a:solidFill>
-                  <a:srgbClr val="0F172A"/>
-                </a:solidFill>
-              </a:defRPr>
-            </a:pPr>
-            <a:r>
-              <a:t>• Loads saved checkpoint: mnist_d0.4_s42.pt</a:t>
+              <a:t>  (Demo sample only — not the reported full-test accuracy.)</a:t>
             </a:r>
             <a:br/>
             <a:r>
-              <a:t>• Evaluates first 10 test images instantly on CPU</a:t>
-            </a:r>
-            <a:br/>
-            <a:r>
-              <a:t>• 100% test accuracy on sample batch (0 training steps executed)</a:t>
+              <a:t>• Formal selected mean test accuracy remains 96.157%.</a:t>
             </a:r>
           </a:p>
           <a:p>

</xml_diff>

<commit_message>
Correct final documentation and scientific wording
</commit_message>
<xml_diff>
--- a/presentation/24CS2032_Dropout_Presentation.pptx
+++ b/presentation/24CS2032_Dropout_Presentation.pptx
@@ -3603,7 +3603,7 @@
               </a:defRPr>
             </a:pPr>
             <a:r>
-              <a:t>2. Stochastic Training Mask (p = drop rate, q = 1 - d)</a:t>
+              <a:t>2. Stochastic Training Mask (d = drop probability, q = 1 - d = keep probability)</a:t>
             </a:r>
           </a:p>
           <a:p>
@@ -3618,7 +3618,7 @@
               </a:defRPr>
             </a:pPr>
             <a:r>
-              <a:t>During training, units are dropped with probability d (retained with keep probability q). Forces each neuron to learn useful features alongside random sub-networks.</a:t>
+              <a:t>During training, units are dropped with drop probability d and retained with keep probability q. Forces each neuron to learn useful features alongside random sub-networks.</a:t>
             </a:r>
           </a:p>
           <a:p>
@@ -3633,7 +3633,7 @@
               </a:defRPr>
             </a:pPr>
             <a:r>
-              <a:t>3. Deterministic Inference (Implicit Ensemble)</a:t>
+              <a:t>3. Deterministic Inference (Model Averaging)</a:t>
             </a:r>
           </a:p>
           <a:p>
@@ -3648,7 +3648,7 @@
               </a:defRPr>
             </a:pPr>
             <a:r>
-              <a:t>At test time, the full network runs deterministically without dropping units, acting as an implicit geometric mean ensemble.</a:t>
+              <a:t>At test time, the full network runs deterministically without dropping units, offering an approximate model-averaging interpretation over thinned subnetworks.</a:t>
             </a:r>
           </a:p>
         </p:txBody>
@@ -5905,7 +5905,7 @@
               </a:defRPr>
             </a:pPr>
             <a:r>
-              <a:t>MNIST Failure Cases (Selected d = 0.4):</a:t>
+              <a:t>MNIST Failure Inspection (Selected d = 0.4):</a:t>
             </a:r>
           </a:p>
           <a:p>
@@ -5917,7 +5917,7 @@
               </a:defRPr>
             </a:pPr>
             <a:r>
-              <a:t>Callouts: True 2 → Pred 3 (conf 0.52)   |   True 9 → Pred 8 (conf 0.91)</a:t>
+              <a:t>The inspected examples include: True 2 → Pred 3 (conf 0.52)   |   True 9 → Pred 8 (conf 0.91)</a:t>
             </a:r>
           </a:p>
         </p:txBody>
@@ -5977,7 +5977,7 @@
               </a:defRPr>
             </a:pPr>
             <a:r>
-              <a:t>Fashion-MNIST Failure Cases (Selected d = 0.2):</a:t>
+              <a:t>Fashion-MNIST Failure Inspection (Selected d = 0.2):</a:t>
             </a:r>
           </a:p>
           <a:p>
@@ -5989,7 +5989,7 @@
               </a:defRPr>
             </a:pPr>
             <a:r>
-              <a:t>Callouts: Coat → Pullover (conf 0.71)   |   Ankle boot → Sneaker (conf 0.99)</a:t>
+              <a:t>The inspected examples include: Coat → Pullover (conf 0.71)   |   Ankle boot → Sneaker (conf 0.99)</a:t>
             </a:r>
           </a:p>
         </p:txBody>
@@ -6049,7 +6049,7 @@
               </a:defRPr>
             </a:pPr>
             <a:r>
-              <a:t>Note: Errors reflect visual stroke &amp; silhouette ambiguities at 28×28 resolution without spatial convolutional inductive bias.</a:t>
+              <a:t>Note: Inspected examples display stroke and silhouette resemblances; they do not establish category-wide concentration or individual failure causes.</a:t>
             </a:r>
           </a:p>
         </p:txBody>
@@ -6491,7 +6491,7 @@
               </a:defRPr>
             </a:pPr>
             <a:r>
-              <a:t>1. Complete Mathematical Implementation: Inverted dropout was built and verified from scratch without any built-in library dependencies.</a:t>
+              <a:t>1. Mathematical Implementation: Manual inverted dropout implemented without built-in dropout primitives; standard PyTorch layers and optimizers were used.</a:t>
             </a:r>
           </a:p>
           <a:p>
@@ -6529,7 +6529,7 @@
               </a:defRPr>
             </a:pPr>
             <a:r>
-              <a:t>3. Critical Negative Finding: Canonical d = 0.5 underperformed the no-dropout baseline on Fashion-MNIST, and rates d &gt;= 0.6 caused underfitting on both benchmarks.</a:t>
+              <a:t>3. Critical Negative Finding: Canonical d = 0.5 underperformed the no-dropout baseline on Fashion-MNIST, and high rates d &gt;= 0.6 produced higher error consistent with stronger underfitting under the fixed training budget.</a:t>
             </a:r>
           </a:p>
           <a:p>

</xml_diff>

<commit_message>
Finalize report and presentation corrections
</commit_message>
<xml_diff>
--- a/presentation/24CS2032_Dropout_Presentation.pptx
+++ b/presentation/24CS2032_Dropout_Presentation.pptx
@@ -3501,7 +3501,7 @@
               </a:defRPr>
             </a:pPr>
             <a:r>
-              <a:t>• Regularization Nuance: Dropout regularizes capacity, but excessive drop rates starve feature flow and cause underfitting.</a:t>
+              <a:t>• Regularization Nuance: Excessive dropout can increase underfitting risk under a fixed training budget.</a:t>
             </a:r>
           </a:p>
         </p:txBody>
@@ -5469,7 +5469,7 @@
             </a:r>
             <a:br/>
             <a:r>
-              <a:t>• Optimizer: Adam vs. SGD + momentum + max-norm</a:t>
+              <a:t>• Optimizer: Adam vs. SGD with momentum. Max-norm variants are separate paper configurations.</a:t>
             </a:r>
           </a:p>
           <a:p>
@@ -6707,7 +6707,7 @@
               </a:defRPr>
             </a:pPr>
             <a:r>
-              <a:t>report/24CS2032_Dropout_Report.pdf (5-page IEEE conference format)</a:t>
+              <a:t>report/24CS2032_Dropout_Report.pdf (IEEE two-column format)</a:t>
             </a:r>
           </a:p>
           <a:p>

</xml_diff>